<commit_message>
business: fix 'wins and losses' — honest perf matrix framing
Surface 16x ops reduction (profiling path, 4 vs 64 ops) as the real
signal. Remove misleading 'wins and losses' phrasing from all pitch
materials and replace with accurate description of cycle overhead vs
ops reduction.

Also regenerate ATOMiK_Investor_Deck.pptx and ATOMiK_Aggie_Angel_Deck.pptx.

Co-Authored-By: Claude Sonnet 4.6 (1M context) <noreply@anthropic.com>
</commit_message>
<xml_diff>
--- a/business/for_codex/01_pitch_materials/ATOMiK_Investor_Deck.pptx
+++ b/business/for_codex/01_pitch_materials/ATOMiK_Investor_Deck.pptx
@@ -3301,7 +3301,7 @@
                 </a:solidFill>
                 <a:latin typeface="Aptos"/>
               </a:rPr>
-              <a:t>PRE-SEED  ·  $2.0M  ·  POST-MONEY SAFE</a:t>
+              <a:t>PRE-SEED  ·  $2.0M TARGET  ·  PLANNED SAFE</a:t>
             </a:r>
           </a:p>
         </p:txBody>
@@ -3353,8 +3353,8 @@
         </p:nvSpPr>
         <p:spPr>
           <a:xfrm>
-            <a:off x="704088" y="1920240"/>
-            <a:ext cx="9326880" cy="502920"/>
+            <a:off x="704088" y="1901952"/>
+            <a:ext cx="5303520" cy="566928"/>
           </a:xfrm>
           <a:prstGeom prst="rect">
             <a:avLst/>
@@ -3373,13 +3373,13 @@
               </a:spcAft>
             </a:pPr>
             <a:r>
-              <a:rPr sz="1500" b="0">
+              <a:rPr sz="1440" b="0">
                 <a:solidFill>
                   <a:srgbClr val="9FB1C7"/>
                 </a:solidFill>
                 <a:latin typeface="Aptos"/>
               </a:rPr>
-              <a:t>State-aware compute architecture that reduces wasted state movement for constrained edge, embedded, and AI workloads.</a:t>
+              <a:t>For edge and embedded teams whose battery, heat, bandwidth, latency, or footprint is constrained by repeated state work.</a:t>
             </a:r>
           </a:p>
         </p:txBody>
@@ -3393,7 +3393,7 @@
         <p:spPr>
           <a:xfrm>
             <a:off x="704088" y="2615184"/>
-            <a:ext cx="2514600" cy="310896"/>
+            <a:ext cx="2331720" cy="310896"/>
           </a:xfrm>
           <a:prstGeom prst="roundRect">
             <a:avLst>
@@ -3440,7 +3440,7 @@
         <p:spPr>
           <a:xfrm>
             <a:off x="813816" y="2688336"/>
-            <a:ext cx="2295144" cy="164592"/>
+            <a:ext cx="2112264" cy="164592"/>
           </a:xfrm>
           <a:prstGeom prst="rect">
             <a:avLst/>
@@ -3465,7 +3465,7 @@
                 </a:solidFill>
                 <a:latin typeface="Aptos"/>
               </a:rPr>
-              <a:t>HARDWARE_VALIDATED on Zynq FPGA</a:t>
+              <a:t>Zynq UI proof</a:t>
             </a:r>
           </a:p>
         </p:txBody>
@@ -3478,8 +3478,8 @@
         </p:nvSpPr>
         <p:spPr>
           <a:xfrm>
-            <a:off x="3383280" y="2615184"/>
-            <a:ext cx="2148840" cy="310896"/>
+            <a:off x="3218688" y="2615184"/>
+            <a:ext cx="2606040" cy="310896"/>
           </a:xfrm>
           <a:prstGeom prst="roundRect">
             <a:avLst>
@@ -3525,8 +3525,8 @@
         </p:nvSpPr>
         <p:spPr>
           <a:xfrm>
-            <a:off x="3493008" y="2688336"/>
-            <a:ext cx="1929384" cy="164592"/>
+            <a:off x="3328416" y="2688336"/>
+            <a:ext cx="2386584" cy="164592"/>
           </a:xfrm>
           <a:prstGeom prst="rect">
             <a:avLst/>
@@ -3551,14 +3551,100 @@
                 </a:solidFill>
                 <a:latin typeface="Aptos"/>
               </a:rPr>
-              <a:t>16/16 algebraic proofs pass</a:t>
-            </a:r>
-          </a:p>
-        </p:txBody>
-      </p:sp>
-      <p:sp>
-        <p:nvSpPr>
-          <p:cNvPr id="13" name="TextBox 12"/>
+              <a:t>Linux-to-FPGA path</a:t>
+            </a:r>
+          </a:p>
+        </p:txBody>
+      </p:sp>
+      <p:sp>
+        <p:nvSpPr>
+          <p:cNvPr id="13" name="Rounded Rectangle 12"/>
+          <p:cNvSpPr/>
+          <p:nvPr/>
+        </p:nvSpPr>
+        <p:spPr>
+          <a:xfrm>
+            <a:off x="6016752" y="2615184"/>
+            <a:ext cx="2697480" cy="310896"/>
+          </a:xfrm>
+          <a:prstGeom prst="roundRect">
+            <a:avLst>
+              <a:gd name="adj" fmla="val 8000"/>
+            </a:avLst>
+          </a:prstGeom>
+          <a:solidFill>
+            <a:srgbClr val="101A29"/>
+          </a:solidFill>
+          <a:ln w="9525">
+            <a:solidFill>
+              <a:srgbClr val="1D324A"/>
+            </a:solidFill>
+          </a:ln>
+        </p:spPr>
+        <p:style>
+          <a:lnRef idx="1">
+            <a:schemeClr val="accent1"/>
+          </a:lnRef>
+          <a:fillRef idx="3">
+            <a:schemeClr val="accent1"/>
+          </a:fillRef>
+          <a:effectRef idx="2">
+            <a:schemeClr val="accent1"/>
+          </a:effectRef>
+          <a:fontRef idx="minor">
+            <a:schemeClr val="lt1"/>
+          </a:fontRef>
+        </p:style>
+        <p:txBody>
+          <a:bodyPr rtlCol="0" anchor="ctr"/>
+          <a:lstStyle/>
+          <a:p>
+            <a:pPr algn="ctr"/>
+          </a:p>
+        </p:txBody>
+      </p:sp>
+      <p:sp>
+        <p:nvSpPr>
+          <p:cNvPr id="14" name="TextBox 13"/>
+          <p:cNvSpPr txBox="1"/>
+          <p:nvPr/>
+        </p:nvSpPr>
+        <p:spPr>
+          <a:xfrm>
+            <a:off x="6126480" y="2688336"/>
+            <a:ext cx="2478024" cy="164592"/>
+          </a:xfrm>
+          <a:prstGeom prst="rect">
+            <a:avLst/>
+          </a:prstGeom>
+          <a:noFill/>
+        </p:spPr>
+        <p:txBody>
+          <a:bodyPr wrap="square" lIns="0" rIns="0" tIns="0" bIns="0" anchor="t">
+            <a:spAutoFit/>
+          </a:bodyPr>
+          <a:lstStyle/>
+          <a:p>
+            <a:pPr algn="ctr">
+              <a:spcAft>
+                <a:spcPts val="0"/>
+              </a:spcAft>
+            </a:pPr>
+            <a:r>
+              <a:rPr sz="850" b="1">
+                <a:solidFill>
+                  <a:srgbClr val="A78BFA"/>
+                </a:solidFill>
+                <a:latin typeface="Aptos"/>
+              </a:rPr>
+              <a:t>16/16 property checks</a:t>
+            </a:r>
+          </a:p>
+        </p:txBody>
+      </p:sp>
+      <p:sp>
+        <p:nvSpPr>
+          <p:cNvPr id="15" name="TextBox 14"/>
           <p:cNvSpPr txBox="1"/>
           <p:nvPr/>
         </p:nvSpPr>
@@ -3590,14 +3676,14 @@
                 </a:solidFill>
                 <a:latin typeface="Aptos"/>
               </a:rPr>
-              <a:t>Every constrained system wastes resources rediscovering what changed. ATOMiK tracks meaningful change instead — reducing bytes moved, operations repeated, and state scanned.</a:t>
+              <a:t>Bring one workload. Measure wasted state movement. Decide fit with evidence.</a:t>
             </a:r>
           </a:p>
         </p:txBody>
       </p:sp>
       <p:pic>
         <p:nvPicPr>
-          <p:cNvPr id="14" name="Picture 13" descr="09-current-live-atomik-desk-v039k.png"/>
+          <p:cNvPr id="16" name="Picture 15" descr="09-current-live-atomik-desk-v039k.png"/>
           <p:cNvPicPr>
             <a:picLocks noChangeAspect="1"/>
           </p:cNvPicPr>
@@ -3611,8 +3697,8 @@
         </p:blipFill>
         <p:spPr>
           <a:xfrm>
-            <a:off x="5623560" y="1104424"/>
-            <a:ext cx="5989320" cy="3368992"/>
+            <a:off x="7784084" y="3035808"/>
+            <a:ext cx="2308352" cy="1298448"/>
           </a:xfrm>
           <a:prstGeom prst="rect">
             <a:avLst/>
@@ -3621,7 +3707,7 @@
       </p:pic>
       <p:sp>
         <p:nvSpPr>
-          <p:cNvPr id="15" name="Rounded Rectangle 14"/>
+          <p:cNvPr id="17" name="Rounded Rectangle 16"/>
           <p:cNvSpPr/>
           <p:nvPr/>
         </p:nvSpPr>
@@ -3668,7 +3754,7 @@
       </p:sp>
       <p:sp>
         <p:nvSpPr>
-          <p:cNvPr id="16" name="Rectangle 15"/>
+          <p:cNvPr id="18" name="Rectangle 17"/>
           <p:cNvSpPr/>
           <p:nvPr/>
         </p:nvSpPr>
@@ -3711,7 +3797,7 @@
       </p:sp>
       <p:sp>
         <p:nvSpPr>
-          <p:cNvPr id="17" name="TextBox 16"/>
+          <p:cNvPr id="19" name="TextBox 18"/>
           <p:cNvSpPr txBox="1"/>
           <p:nvPr/>
         </p:nvSpPr>
@@ -3750,7 +3836,7 @@
       </p:sp>
       <p:sp>
         <p:nvSpPr>
-          <p:cNvPr id="18" name="TextBox 17"/>
+          <p:cNvPr id="20" name="TextBox 19"/>
           <p:cNvSpPr txBox="1"/>
           <p:nvPr/>
         </p:nvSpPr>
@@ -3782,14 +3868,14 @@
                 </a:solidFill>
                 <a:latin typeface="Aptos"/>
               </a:rPr>
-              <a:t>Architecture + implementation + workload evidence → licensing or strategic acquisition</a:t>
-            </a:r>
-          </a:p>
-        </p:txBody>
-      </p:sp>
-      <p:sp>
-        <p:nvSpPr>
-          <p:cNvPr id="19" name="Rounded Rectangle 18"/>
+              <a:t>Architecture + proof + IP packet</a:t>
+            </a:r>
+          </a:p>
+        </p:txBody>
+      </p:sp>
+      <p:sp>
+        <p:nvSpPr>
+          <p:cNvPr id="21" name="Rounded Rectangle 20"/>
           <p:cNvSpPr/>
           <p:nvPr/>
         </p:nvSpPr>
@@ -3836,7 +3922,7 @@
       </p:sp>
       <p:sp>
         <p:nvSpPr>
-          <p:cNvPr id="20" name="Rectangle 19"/>
+          <p:cNvPr id="22" name="Rectangle 21"/>
           <p:cNvSpPr/>
           <p:nvPr/>
         </p:nvSpPr>
@@ -3879,7 +3965,7 @@
       </p:sp>
       <p:sp>
         <p:nvSpPr>
-          <p:cNvPr id="21" name="TextBox 20"/>
+          <p:cNvPr id="23" name="TextBox 22"/>
           <p:cNvSpPr txBox="1"/>
           <p:nvPr/>
         </p:nvSpPr>
@@ -3918,7 +4004,7 @@
       </p:sp>
       <p:sp>
         <p:nvSpPr>
-          <p:cNvPr id="22" name="TextBox 21"/>
+          <p:cNvPr id="24" name="TextBox 23"/>
           <p:cNvSpPr txBox="1"/>
           <p:nvPr/>
         </p:nvSpPr>
@@ -3950,14 +4036,14 @@
                 </a:solidFill>
                 <a:latin typeface="Aptos"/>
               </a:rPr>
-              <a:t>ATOMiK Desk v0.39-K running on Zynq hardware today</a:t>
-            </a:r>
-          </a:p>
-        </p:txBody>
-      </p:sp>
-      <p:sp>
-        <p:nvSpPr>
-          <p:cNvPr id="23" name="Rounded Rectangle 22"/>
+              <a:t>v0.39-K running on Zynq</a:t>
+            </a:r>
+          </a:p>
+        </p:txBody>
+      </p:sp>
+      <p:sp>
+        <p:nvSpPr>
+          <p:cNvPr id="25" name="Rounded Rectangle 24"/>
           <p:cNvSpPr/>
           <p:nvPr/>
         </p:nvSpPr>
@@ -4004,7 +4090,7 @@
       </p:sp>
       <p:sp>
         <p:nvSpPr>
-          <p:cNvPr id="24" name="Rectangle 23"/>
+          <p:cNvPr id="26" name="Rectangle 25"/>
           <p:cNvSpPr/>
           <p:nvPr/>
         </p:nvSpPr>
@@ -4047,7 +4133,7 @@
       </p:sp>
       <p:sp>
         <p:nvSpPr>
-          <p:cNvPr id="25" name="TextBox 24"/>
+          <p:cNvPr id="27" name="TextBox 26"/>
           <p:cNvSpPr txBox="1"/>
           <p:nvPr/>
         </p:nvSpPr>
@@ -4086,7 +4172,7 @@
       </p:sp>
       <p:sp>
         <p:nvSpPr>
-          <p:cNvPr id="26" name="TextBox 25"/>
+          <p:cNvPr id="28" name="TextBox 27"/>
           <p:cNvSpPr txBox="1"/>
           <p:nvPr/>
         </p:nvSpPr>
@@ -4118,7 +4204,7 @@
                 </a:solidFill>
                 <a:latin typeface="Aptos"/>
               </a:rPr>
-              <a:t>$2M funds measured customer proof + IP diligence + ASIC feasibility</a:t>
+              <a:t>measured workload proof + IP diligence</a:t>
             </a:r>
           </a:p>
         </p:txBody>
@@ -4395,8 +4481,8 @@
         </p:nvSpPr>
         <p:spPr>
           <a:xfrm>
-            <a:off x="777240" y="1828800"/>
-            <a:ext cx="3337560" cy="1060704"/>
+            <a:off x="777240" y="2240280"/>
+            <a:ext cx="3337560" cy="932688"/>
           </a:xfrm>
           <a:prstGeom prst="roundRect">
             <a:avLst>
@@ -4442,7 +4528,7 @@
         </p:nvSpPr>
         <p:spPr>
           <a:xfrm>
-            <a:off x="941832" y="1975104"/>
+            <a:off x="941832" y="2386584"/>
             <a:ext cx="566928" cy="38100"/>
           </a:xfrm>
           <a:prstGeom prst="rect">
@@ -4485,7 +4571,7 @@
         </p:nvSpPr>
         <p:spPr>
           <a:xfrm>
-            <a:off x="941832" y="2157984"/>
+            <a:off x="941832" y="2569464"/>
             <a:ext cx="3008376" cy="274320"/>
           </a:xfrm>
           <a:prstGeom prst="rect">
@@ -4524,8 +4610,8 @@
         </p:nvSpPr>
         <p:spPr>
           <a:xfrm>
-            <a:off x="941832" y="2532888"/>
-            <a:ext cx="3008376" cy="237744"/>
+            <a:off x="941832" y="2944368"/>
+            <a:ext cx="3008376" cy="109728"/>
           </a:xfrm>
           <a:prstGeom prst="rect">
             <a:avLst/>
@@ -4544,7 +4630,7 @@
               </a:spcAft>
             </a:pPr>
             <a:r>
-              <a:rPr sz="1019" b="0">
+              <a:rPr sz="940" b="0">
                 <a:solidFill>
                   <a:srgbClr val="9FB1C7"/>
                 </a:solidFill>
@@ -4563,8 +4649,8 @@
         </p:nvSpPr>
         <p:spPr>
           <a:xfrm>
-            <a:off x="4526279" y="1828800"/>
-            <a:ext cx="3337560" cy="1060704"/>
+            <a:off x="4526279" y="2240280"/>
+            <a:ext cx="3337560" cy="932688"/>
           </a:xfrm>
           <a:prstGeom prst="roundRect">
             <a:avLst>
@@ -4610,7 +4696,7 @@
         </p:nvSpPr>
         <p:spPr>
           <a:xfrm>
-            <a:off x="4690871" y="1975104"/>
+            <a:off x="4690871" y="2386584"/>
             <a:ext cx="566928" cy="38100"/>
           </a:xfrm>
           <a:prstGeom prst="rect">
@@ -4653,7 +4739,7 @@
         </p:nvSpPr>
         <p:spPr>
           <a:xfrm>
-            <a:off x="4690871" y="2157984"/>
+            <a:off x="4690871" y="2569464"/>
             <a:ext cx="3008376" cy="274320"/>
           </a:xfrm>
           <a:prstGeom prst="rect">
@@ -4692,8 +4778,8 @@
         </p:nvSpPr>
         <p:spPr>
           <a:xfrm>
-            <a:off x="4690871" y="2532888"/>
-            <a:ext cx="3008376" cy="237744"/>
+            <a:off x="4690871" y="2944368"/>
+            <a:ext cx="3008376" cy="109728"/>
           </a:xfrm>
           <a:prstGeom prst="rect">
             <a:avLst/>
@@ -4712,7 +4798,7 @@
               </a:spcAft>
             </a:pPr>
             <a:r>
-              <a:rPr sz="1019" b="0">
+              <a:rPr sz="940" b="0">
                 <a:solidFill>
                   <a:srgbClr val="9FB1C7"/>
                 </a:solidFill>
@@ -4731,8 +4817,8 @@
         </p:nvSpPr>
         <p:spPr>
           <a:xfrm>
-            <a:off x="8275319" y="1828800"/>
-            <a:ext cx="3337560" cy="1060704"/>
+            <a:off x="8275319" y="2240280"/>
+            <a:ext cx="3337560" cy="932688"/>
           </a:xfrm>
           <a:prstGeom prst="roundRect">
             <a:avLst>
@@ -4778,7 +4864,7 @@
         </p:nvSpPr>
         <p:spPr>
           <a:xfrm>
-            <a:off x="8439911" y="1975104"/>
+            <a:off x="8439911" y="2386584"/>
             <a:ext cx="566928" cy="38100"/>
           </a:xfrm>
           <a:prstGeom prst="rect">
@@ -4821,7 +4907,7 @@
         </p:nvSpPr>
         <p:spPr>
           <a:xfrm>
-            <a:off x="8439911" y="2157984"/>
+            <a:off x="8439911" y="2569464"/>
             <a:ext cx="3008376" cy="274320"/>
           </a:xfrm>
           <a:prstGeom prst="rect">
@@ -4860,8 +4946,8 @@
         </p:nvSpPr>
         <p:spPr>
           <a:xfrm>
-            <a:off x="8439911" y="2532888"/>
-            <a:ext cx="3008376" cy="237744"/>
+            <a:off x="8439911" y="2944368"/>
+            <a:ext cx="3008376" cy="109728"/>
           </a:xfrm>
           <a:prstGeom prst="rect">
             <a:avLst/>
@@ -4880,7 +4966,7 @@
               </a:spcAft>
             </a:pPr>
             <a:r>
-              <a:rPr sz="1019" b="0">
+              <a:rPr sz="940" b="0">
                 <a:solidFill>
                   <a:srgbClr val="9FB1C7"/>
                 </a:solidFill>
@@ -4899,8 +4985,8 @@
         </p:nvSpPr>
         <p:spPr>
           <a:xfrm>
-            <a:off x="777240" y="3246120"/>
-            <a:ext cx="3337560" cy="1060704"/>
+            <a:off x="777240" y="3502152"/>
+            <a:ext cx="3337560" cy="932688"/>
           </a:xfrm>
           <a:prstGeom prst="roundRect">
             <a:avLst>
@@ -4946,7 +5032,7 @@
         </p:nvSpPr>
         <p:spPr>
           <a:xfrm>
-            <a:off x="941832" y="3392424"/>
+            <a:off x="941832" y="3648456"/>
             <a:ext cx="566928" cy="38100"/>
           </a:xfrm>
           <a:prstGeom prst="rect">
@@ -4989,7 +5075,7 @@
         </p:nvSpPr>
         <p:spPr>
           <a:xfrm>
-            <a:off x="941832" y="3575304"/>
+            <a:off x="941832" y="3831336"/>
             <a:ext cx="3008376" cy="274320"/>
           </a:xfrm>
           <a:prstGeom prst="rect">
@@ -5028,8 +5114,8 @@
         </p:nvSpPr>
         <p:spPr>
           <a:xfrm>
-            <a:off x="941832" y="3950208"/>
-            <a:ext cx="3008376" cy="237744"/>
+            <a:off x="941832" y="4206240"/>
+            <a:ext cx="3008376" cy="109728"/>
           </a:xfrm>
           <a:prstGeom prst="rect">
             <a:avLst/>
@@ -5048,7 +5134,7 @@
               </a:spcAft>
             </a:pPr>
             <a:r>
-              <a:rPr sz="1019" b="0">
+              <a:rPr sz="940" b="0">
                 <a:solidFill>
                   <a:srgbClr val="9FB1C7"/>
                 </a:solidFill>
@@ -5067,8 +5153,8 @@
         </p:nvSpPr>
         <p:spPr>
           <a:xfrm>
-            <a:off x="4526279" y="3246120"/>
-            <a:ext cx="3337560" cy="1060704"/>
+            <a:off x="4526279" y="3502152"/>
+            <a:ext cx="3337560" cy="932688"/>
           </a:xfrm>
           <a:prstGeom prst="roundRect">
             <a:avLst>
@@ -5114,7 +5200,7 @@
         </p:nvSpPr>
         <p:spPr>
           <a:xfrm>
-            <a:off x="4690871" y="3392424"/>
+            <a:off x="4690871" y="3648456"/>
             <a:ext cx="566928" cy="38100"/>
           </a:xfrm>
           <a:prstGeom prst="rect">
@@ -5157,7 +5243,7 @@
         </p:nvSpPr>
         <p:spPr>
           <a:xfrm>
-            <a:off x="4690871" y="3575304"/>
+            <a:off x="4690871" y="3831336"/>
             <a:ext cx="3008376" cy="274320"/>
           </a:xfrm>
           <a:prstGeom prst="rect">
@@ -5196,8 +5282,8 @@
         </p:nvSpPr>
         <p:spPr>
           <a:xfrm>
-            <a:off x="4690871" y="3950208"/>
-            <a:ext cx="3008376" cy="237744"/>
+            <a:off x="4690871" y="4206240"/>
+            <a:ext cx="3008376" cy="109728"/>
           </a:xfrm>
           <a:prstGeom prst="rect">
             <a:avLst/>
@@ -5216,7 +5302,7 @@
               </a:spcAft>
             </a:pPr>
             <a:r>
-              <a:rPr sz="1019" b="0">
+              <a:rPr sz="940" b="0">
                 <a:solidFill>
                   <a:srgbClr val="9FB1C7"/>
                 </a:solidFill>
@@ -5235,8 +5321,8 @@
         </p:nvSpPr>
         <p:spPr>
           <a:xfrm>
-            <a:off x="8275319" y="3246120"/>
-            <a:ext cx="3337560" cy="1060704"/>
+            <a:off x="8275319" y="3502152"/>
+            <a:ext cx="3337560" cy="932688"/>
           </a:xfrm>
           <a:prstGeom prst="roundRect">
             <a:avLst>
@@ -5282,7 +5368,7 @@
         </p:nvSpPr>
         <p:spPr>
           <a:xfrm>
-            <a:off x="8439911" y="3392424"/>
+            <a:off x="8439911" y="3648456"/>
             <a:ext cx="566928" cy="38100"/>
           </a:xfrm>
           <a:prstGeom prst="rect">
@@ -5325,7 +5411,7 @@
         </p:nvSpPr>
         <p:spPr>
           <a:xfrm>
-            <a:off x="8439911" y="3575304"/>
+            <a:off x="8439911" y="3831336"/>
             <a:ext cx="3008376" cy="274320"/>
           </a:xfrm>
           <a:prstGeom prst="rect">
@@ -5364,8 +5450,8 @@
         </p:nvSpPr>
         <p:spPr>
           <a:xfrm>
-            <a:off x="8439911" y="3950208"/>
-            <a:ext cx="3008376" cy="237744"/>
+            <a:off x="8439911" y="4206240"/>
+            <a:ext cx="3008376" cy="109728"/>
           </a:xfrm>
           <a:prstGeom prst="rect">
             <a:avLst/>
@@ -5384,7 +5470,7 @@
               </a:spcAft>
             </a:pPr>
             <a:r>
-              <a:rPr sz="1019" b="0">
+              <a:rPr sz="940" b="0">
                 <a:solidFill>
                   <a:srgbClr val="9FB1C7"/>
                 </a:solidFill>
@@ -5423,7 +5509,7 @@
               </a:spcAft>
             </a:pPr>
             <a:r>
-              <a:rPr sz="1420" b="0">
+              <a:rPr sz="1350" b="0">
                 <a:solidFill>
                   <a:srgbClr val="6F8097"/>
                 </a:solidFill>
@@ -5706,8 +5792,8 @@
         </p:nvSpPr>
         <p:spPr>
           <a:xfrm>
-            <a:off x="822960" y="1920240"/>
-            <a:ext cx="4892040" cy="1115568"/>
+            <a:off x="822960" y="2240280"/>
+            <a:ext cx="4892040" cy="987552"/>
           </a:xfrm>
           <a:prstGeom prst="roundRect">
             <a:avLst>
@@ -5753,7 +5839,7 @@
         </p:nvSpPr>
         <p:spPr>
           <a:xfrm>
-            <a:off x="987552" y="2066544"/>
+            <a:off x="987552" y="2386584"/>
             <a:ext cx="566928" cy="38100"/>
           </a:xfrm>
           <a:prstGeom prst="rect">
@@ -5796,7 +5882,7 @@
         </p:nvSpPr>
         <p:spPr>
           <a:xfrm>
-            <a:off x="987552" y="2249424"/>
+            <a:off x="987552" y="2569464"/>
             <a:ext cx="4562856" cy="274320"/>
           </a:xfrm>
           <a:prstGeom prst="rect">
@@ -5835,8 +5921,8 @@
         </p:nvSpPr>
         <p:spPr>
           <a:xfrm>
-            <a:off x="987552" y="2624328"/>
-            <a:ext cx="4562856" cy="292608"/>
+            <a:off x="987552" y="2944368"/>
+            <a:ext cx="4562856" cy="164592"/>
           </a:xfrm>
           <a:prstGeom prst="rect">
             <a:avLst/>
@@ -5855,7 +5941,7 @@
               </a:spcAft>
             </a:pPr>
             <a:r>
-              <a:rPr sz="1100" b="0">
+              <a:rPr sz="1050" b="0">
                 <a:solidFill>
                   <a:srgbClr val="9FB1C7"/>
                 </a:solidFill>
@@ -5874,8 +5960,8 @@
         </p:nvSpPr>
         <p:spPr>
           <a:xfrm>
-            <a:off x="6217920" y="1920240"/>
-            <a:ext cx="4892040" cy="1115568"/>
+            <a:off x="6217920" y="2240280"/>
+            <a:ext cx="4892040" cy="987552"/>
           </a:xfrm>
           <a:prstGeom prst="roundRect">
             <a:avLst>
@@ -5921,7 +6007,7 @@
         </p:nvSpPr>
         <p:spPr>
           <a:xfrm>
-            <a:off x="6382512" y="2066544"/>
+            <a:off x="6382512" y="2386584"/>
             <a:ext cx="566928" cy="38100"/>
           </a:xfrm>
           <a:prstGeom prst="rect">
@@ -5964,7 +6050,7 @@
         </p:nvSpPr>
         <p:spPr>
           <a:xfrm>
-            <a:off x="6382512" y="2249424"/>
+            <a:off x="6382512" y="2569464"/>
             <a:ext cx="4562856" cy="274320"/>
           </a:xfrm>
           <a:prstGeom prst="rect">
@@ -6003,8 +6089,8 @@
         </p:nvSpPr>
         <p:spPr>
           <a:xfrm>
-            <a:off x="6382512" y="2624328"/>
-            <a:ext cx="4562856" cy="292608"/>
+            <a:off x="6382512" y="2944368"/>
+            <a:ext cx="4562856" cy="164592"/>
           </a:xfrm>
           <a:prstGeom prst="rect">
             <a:avLst/>
@@ -6023,7 +6109,7 @@
               </a:spcAft>
             </a:pPr>
             <a:r>
-              <a:rPr sz="1100" b="0">
+              <a:rPr sz="1050" b="0">
                 <a:solidFill>
                   <a:srgbClr val="9FB1C7"/>
                 </a:solidFill>
@@ -6042,8 +6128,8 @@
         </p:nvSpPr>
         <p:spPr>
           <a:xfrm>
-            <a:off x="822960" y="3429000"/>
-            <a:ext cx="4892040" cy="1115568"/>
+            <a:off x="822960" y="3538728"/>
+            <a:ext cx="4892040" cy="987552"/>
           </a:xfrm>
           <a:prstGeom prst="roundRect">
             <a:avLst>
@@ -6089,7 +6175,7 @@
         </p:nvSpPr>
         <p:spPr>
           <a:xfrm>
-            <a:off x="987552" y="3575304"/>
+            <a:off x="987552" y="3685032"/>
             <a:ext cx="566928" cy="38100"/>
           </a:xfrm>
           <a:prstGeom prst="rect">
@@ -6132,7 +6218,7 @@
         </p:nvSpPr>
         <p:spPr>
           <a:xfrm>
-            <a:off x="987552" y="3758184"/>
+            <a:off x="987552" y="3867912"/>
             <a:ext cx="4562856" cy="274320"/>
           </a:xfrm>
           <a:prstGeom prst="rect">
@@ -6171,8 +6257,8 @@
         </p:nvSpPr>
         <p:spPr>
           <a:xfrm>
-            <a:off x="987552" y="4133088"/>
-            <a:ext cx="4562856" cy="292608"/>
+            <a:off x="987552" y="4242816"/>
+            <a:ext cx="4562856" cy="164592"/>
           </a:xfrm>
           <a:prstGeom prst="rect">
             <a:avLst/>
@@ -6191,7 +6277,7 @@
               </a:spcAft>
             </a:pPr>
             <a:r>
-              <a:rPr sz="1100" b="0">
+              <a:rPr sz="1050" b="0">
                 <a:solidFill>
                   <a:srgbClr val="9FB1C7"/>
                 </a:solidFill>
@@ -6210,8 +6296,8 @@
         </p:nvSpPr>
         <p:spPr>
           <a:xfrm>
-            <a:off x="6217920" y="3429000"/>
-            <a:ext cx="4892040" cy="1115568"/>
+            <a:off x="6217920" y="3538728"/>
+            <a:ext cx="4892040" cy="987552"/>
           </a:xfrm>
           <a:prstGeom prst="roundRect">
             <a:avLst>
@@ -6257,7 +6343,7 @@
         </p:nvSpPr>
         <p:spPr>
           <a:xfrm>
-            <a:off x="6382512" y="3575304"/>
+            <a:off x="6382512" y="3685032"/>
             <a:ext cx="566928" cy="38100"/>
           </a:xfrm>
           <a:prstGeom prst="rect">
@@ -6300,7 +6386,7 @@
         </p:nvSpPr>
         <p:spPr>
           <a:xfrm>
-            <a:off x="6382512" y="3758184"/>
+            <a:off x="6382512" y="3867912"/>
             <a:ext cx="4562856" cy="274320"/>
           </a:xfrm>
           <a:prstGeom prst="rect">
@@ -6339,8 +6425,8 @@
         </p:nvSpPr>
         <p:spPr>
           <a:xfrm>
-            <a:off x="6382512" y="4133088"/>
-            <a:ext cx="4562856" cy="292608"/>
+            <a:off x="6382512" y="4242816"/>
+            <a:ext cx="4562856" cy="164592"/>
           </a:xfrm>
           <a:prstGeom prst="rect">
             <a:avLst/>
@@ -6359,7 +6445,7 @@
               </a:spcAft>
             </a:pPr>
             <a:r>
-              <a:rPr sz="1100" b="0">
+              <a:rPr sz="1050" b="0">
                 <a:solidFill>
                   <a:srgbClr val="9FB1C7"/>
                 </a:solidFill>
@@ -6378,7 +6464,7 @@
         </p:nvSpPr>
         <p:spPr>
           <a:xfrm>
-            <a:off x="914400" y="5257800"/>
+            <a:off x="914400" y="5193792"/>
             <a:ext cx="10424160" cy="365760"/>
           </a:xfrm>
           <a:prstGeom prst="rect">
@@ -6398,7 +6484,7 @@
               </a:spcAft>
             </a:pPr>
             <a:r>
-              <a:rPr sz="1800" b="1">
+              <a:rPr sz="1700" b="1">
                 <a:solidFill>
                   <a:srgbClr val="F4F8FF"/>
                 </a:solidFill>
@@ -6668,7 +6754,7 @@
                 </a:solidFill>
                 <a:latin typeface="Aptos"/>
               </a:rPr>
-              <a:t>Raising $2.0M to become a strategic acquisition target</a:t>
+              <a:t>$2.0M target to reach measured workload proof</a:t>
             </a:r>
           </a:p>
         </p:txBody>
@@ -6716,7 +6802,7 @@
                 </a:solidFill>
                 <a:latin typeface="Aptos"/>
               </a:rPr>
-              <a:t>$2.0M target pre-seed  ·  $1.25M minimum close  ·  $2.75M stretch</a:t>
+              <a:t>$2.0M target  ·  $1.25M minimum  ·  $2.75M stretch</a:t>
             </a:r>
           </a:p>
           <a:p>
@@ -6741,7 +6827,7 @@
                 </a:solidFill>
                 <a:latin typeface="Aptos"/>
               </a:rPr>
-              <a:t>Post-money SAFE  ·  final terms require CFO/counsel review</a:t>
+              <a:t>Planned SAFE; final terms counsel/CFO pending</a:t>
             </a:r>
           </a:p>
           <a:p>
@@ -6766,7 +6852,7 @@
                 </a:solidFill>
                 <a:latin typeface="Aptos"/>
               </a:rPr>
-              <a:t>18 months of runway to measured proof, IP diligence, and ASIC feasibility</a:t>
+              <a:t>18 months to workload proof, IP packet, ASIC feasibility</a:t>
             </a:r>
           </a:p>
           <a:p>
@@ -6791,7 +6877,7 @@
                 </a:solidFill>
                 <a:latin typeface="Aptos"/>
               </a:rPr>
-              <a:t>Design-partner introductions and customer workload access</a:t>
+              <a:t>Need: capital, workload access, design-partner intros</a:t>
             </a:r>
           </a:p>
         </p:txBody>
@@ -6916,7 +7002,7 @@
                 </a:solidFill>
                 <a:latin typeface="Aptos"/>
               </a:rPr>
-              <a:t>Proof is achievable at pre-seed scale. The gap between current hardware validation and defensible IP is $2M, not $20M. That gap is the entry point.</a:t>
+              <a:t>Next risk: prove customer workload value before tape-out.</a:t>
             </a:r>
           </a:p>
         </p:txBody>
@@ -7084,7 +7170,7 @@
                 </a:solidFill>
                 <a:latin typeface="Aptos"/>
               </a:rPr>
-              <a:t>$2.0M pre-seed</a:t>
+              <a:t>$2.0M</a:t>
             </a:r>
           </a:p>
         </p:txBody>
@@ -7252,7 +7338,7 @@
                 </a:solidFill>
                 <a:latin typeface="Aptos"/>
               </a:rPr>
-              <a:t>Measured proof + IP packet + ASIC feasibility</a:t>
+              <a:t>proof + IP + ASIC feasibility</a:t>
             </a:r>
           </a:p>
         </p:txBody>
@@ -7420,7 +7506,7 @@
                 </a:solidFill>
                 <a:latin typeface="Aptos"/>
               </a:rPr>
-              <a:t>Acquisition by chip/platform company at IP premium</a:t>
+              <a:t>options if proof holds</a:t>
             </a:r>
           </a:p>
         </p:txBody>
@@ -7723,7 +7809,7 @@
                 </a:solidFill>
                 <a:latin typeface="Aptos"/>
               </a:rPr>
-              <a:t>Constrained systems pay a hidden tax on unchanged state</a:t>
+              <a:t>The hidden tax is repeated state work</a:t>
             </a:r>
           </a:p>
         </p:txBody>
@@ -7771,7 +7857,7 @@
                 </a:solidFill>
                 <a:latin typeface="Aptos"/>
               </a:rPr>
-              <a:t>Data-center energy: 415 TWh in 2024 → projected 945 TWh by 2030. (IEA)</a:t>
+              <a:t>Battery, heat, link budget, latency, and reliability pressure.</a:t>
             </a:r>
           </a:p>
           <a:p>
@@ -7796,7 +7882,7 @@
                 </a:solidFill>
                 <a:latin typeface="Aptos"/>
               </a:rPr>
-              <a:t>U.S. alone: 176 TWh in 2023 → 325–580 TWh projected by 2028. (LBNL)</a:t>
+              <a:t>AI/context and remote systems make state movement expensive.</a:t>
             </a:r>
           </a:p>
           <a:p>
@@ -7821,7 +7907,7 @@
                 </a:solidFill>
                 <a:latin typeface="Aptos"/>
               </a:rPr>
-              <a:t>66 billion liters of direct cooling water consumed in U.S. data centers in 2023.</a:t>
+              <a:t>Market energy and water data explain urgency, not ATOMiK savings.</a:t>
             </a:r>
           </a:p>
           <a:p>
@@ -7846,32 +7932,7 @@
                 </a:solidFill>
                 <a:latin typeface="Aptos"/>
               </a:rPr>
-              <a:t>Edge and embedded teams hit hard limits on battery, heat, and bandwidth — before data center scale.</a:t>
-            </a:r>
-          </a:p>
-          <a:p>
-            <a:pPr>
-              <a:spcAft>
-                <a:spcPts val="700"/>
-              </a:spcAft>
-            </a:pPr>
-            <a:r>
-              <a:rPr sz="1550">
-                <a:solidFill>
-                  <a:srgbClr val="F59E0B"/>
-                </a:solidFill>
-                <a:latin typeface="Aptos"/>
-              </a:rPr>
-              <a:t>- </a:t>
-            </a:r>
-            <a:r>
-              <a:rPr sz="1550">
-                <a:solidFill>
-                  <a:srgbClr val="9FB1C7"/>
-                </a:solidFill>
-                <a:latin typeface="Aptos"/>
-              </a:rPr>
-              <a:t>In every case: the system processes state it already knows. Most of it didn't change.</a:t>
+              <a:t>Common pattern: full-state work when only a compact change matters.</a:t>
             </a:r>
           </a:p>
         </p:txBody>
@@ -8039,7 +8100,7 @@
                 </a:solidFill>
                 <a:latin typeface="Aptos"/>
               </a:rPr>
-              <a:t>Redundant state movement burns power and generates thermal load in sealed devices.</a:t>
+              <a:t>Power and thermal pressure.</a:t>
             </a:r>
           </a:p>
         </p:txBody>
@@ -8207,7 +8268,7 @@
                 </a:solidFill>
                 <a:latin typeface="Aptos"/>
               </a:rPr>
-              <a:t>Full-state sync over constrained links moves more than necessary, every tick.</a:t>
+              <a:t>Link budget pressure.</a:t>
             </a:r>
           </a:p>
         </p:txBody>
@@ -8375,7 +8436,7 @@
                 </a:solidFill>
                 <a:latin typeface="Aptos"/>
               </a:rPr>
-              <a:t>Rebuilding or replaying state instead of tracking delta adds delay where it hurts.</a:t>
+              <a:t>Local-response delay.</a:t>
             </a:r>
           </a:p>
         </p:txBody>
@@ -11452,8 +11513,8 @@
         </p:nvSpPr>
         <p:spPr>
           <a:xfrm>
-            <a:off x="777240" y="1828800"/>
-            <a:ext cx="4983480" cy="1325880"/>
+            <a:off x="777240" y="2240280"/>
+            <a:ext cx="4983480" cy="1170432"/>
           </a:xfrm>
           <a:prstGeom prst="roundRect">
             <a:avLst>
@@ -11499,7 +11560,7 @@
         </p:nvSpPr>
         <p:spPr>
           <a:xfrm>
-            <a:off x="941832" y="1975104"/>
+            <a:off x="941832" y="2386584"/>
             <a:ext cx="658368" cy="38100"/>
           </a:xfrm>
           <a:prstGeom prst="rect">
@@ -11542,7 +11603,7 @@
         </p:nvSpPr>
         <p:spPr>
           <a:xfrm>
-            <a:off x="941832" y="2157984"/>
+            <a:off x="941832" y="2569464"/>
             <a:ext cx="4572000" cy="256032"/>
           </a:xfrm>
           <a:prstGeom prst="rect">
@@ -11581,7 +11642,7 @@
         </p:nvSpPr>
         <p:spPr>
           <a:xfrm>
-            <a:off x="941832" y="2514600"/>
+            <a:off x="941832" y="2926080"/>
             <a:ext cx="4572000" cy="201168"/>
           </a:xfrm>
           <a:prstGeom prst="rect">
@@ -11620,7 +11681,7 @@
         </p:nvSpPr>
         <p:spPr>
           <a:xfrm>
-            <a:off x="941832" y="2788920"/>
+            <a:off x="941832" y="3200400"/>
             <a:ext cx="4572000" cy="201168"/>
           </a:xfrm>
           <a:prstGeom prst="rect">
@@ -11659,8 +11720,8 @@
         </p:nvSpPr>
         <p:spPr>
           <a:xfrm>
-            <a:off x="6309359" y="1828800"/>
-            <a:ext cx="4983480" cy="1325880"/>
+            <a:off x="6309359" y="2240280"/>
+            <a:ext cx="4983480" cy="1170432"/>
           </a:xfrm>
           <a:prstGeom prst="roundRect">
             <a:avLst>
@@ -11706,7 +11767,7 @@
         </p:nvSpPr>
         <p:spPr>
           <a:xfrm>
-            <a:off x="6473951" y="1975104"/>
+            <a:off x="6473951" y="2386584"/>
             <a:ext cx="658368" cy="38100"/>
           </a:xfrm>
           <a:prstGeom prst="rect">
@@ -11749,7 +11810,7 @@
         </p:nvSpPr>
         <p:spPr>
           <a:xfrm>
-            <a:off x="6473951" y="2157984"/>
+            <a:off x="6473951" y="2569464"/>
             <a:ext cx="4572000" cy="256032"/>
           </a:xfrm>
           <a:prstGeom prst="rect">
@@ -11788,7 +11849,7 @@
         </p:nvSpPr>
         <p:spPr>
           <a:xfrm>
-            <a:off x="6473951" y="2514600"/>
+            <a:off x="6473951" y="2926080"/>
             <a:ext cx="4572000" cy="201168"/>
           </a:xfrm>
           <a:prstGeom prst="rect">
@@ -11827,7 +11888,7 @@
         </p:nvSpPr>
         <p:spPr>
           <a:xfrm>
-            <a:off x="6473951" y="2788920"/>
+            <a:off x="6473951" y="3200400"/>
             <a:ext cx="4572000" cy="201168"/>
           </a:xfrm>
           <a:prstGeom prst="rect">
@@ -11866,8 +11927,8 @@
         </p:nvSpPr>
         <p:spPr>
           <a:xfrm>
-            <a:off x="777240" y="3520440"/>
-            <a:ext cx="4983480" cy="1325880"/>
+            <a:off x="777240" y="3749039"/>
+            <a:ext cx="4983480" cy="1170432"/>
           </a:xfrm>
           <a:prstGeom prst="roundRect">
             <a:avLst>
@@ -11913,7 +11974,7 @@
         </p:nvSpPr>
         <p:spPr>
           <a:xfrm>
-            <a:off x="941832" y="3666744"/>
+            <a:off x="941832" y="3895343"/>
             <a:ext cx="658368" cy="38100"/>
           </a:xfrm>
           <a:prstGeom prst="rect">
@@ -11956,7 +12017,7 @@
         </p:nvSpPr>
         <p:spPr>
           <a:xfrm>
-            <a:off x="941832" y="3849624"/>
+            <a:off x="941832" y="4078223"/>
             <a:ext cx="4572000" cy="256032"/>
           </a:xfrm>
           <a:prstGeom prst="rect">
@@ -11995,7 +12056,7 @@
         </p:nvSpPr>
         <p:spPr>
           <a:xfrm>
-            <a:off x="941832" y="4206240"/>
+            <a:off x="941832" y="4434839"/>
             <a:ext cx="4572000" cy="201168"/>
           </a:xfrm>
           <a:prstGeom prst="rect">
@@ -12034,7 +12095,7 @@
         </p:nvSpPr>
         <p:spPr>
           <a:xfrm>
-            <a:off x="941832" y="4480560"/>
+            <a:off x="941832" y="4709159"/>
             <a:ext cx="4572000" cy="201168"/>
           </a:xfrm>
           <a:prstGeom prst="rect">
@@ -12073,8 +12134,8 @@
         </p:nvSpPr>
         <p:spPr>
           <a:xfrm>
-            <a:off x="6309359" y="3520440"/>
-            <a:ext cx="4983480" cy="1325880"/>
+            <a:off x="6309359" y="3749039"/>
+            <a:ext cx="4983480" cy="1170432"/>
           </a:xfrm>
           <a:prstGeom prst="roundRect">
             <a:avLst>
@@ -12120,7 +12181,7 @@
         </p:nvSpPr>
         <p:spPr>
           <a:xfrm>
-            <a:off x="6473951" y="3666744"/>
+            <a:off x="6473951" y="3895343"/>
             <a:ext cx="658368" cy="38100"/>
           </a:xfrm>
           <a:prstGeom prst="rect">
@@ -12163,7 +12224,7 @@
         </p:nvSpPr>
         <p:spPr>
           <a:xfrm>
-            <a:off x="6473951" y="3849624"/>
+            <a:off x="6473951" y="4078223"/>
             <a:ext cx="4572000" cy="256032"/>
           </a:xfrm>
           <a:prstGeom prst="rect">
@@ -12202,7 +12263,7 @@
         </p:nvSpPr>
         <p:spPr>
           <a:xfrm>
-            <a:off x="6473951" y="4206240"/>
+            <a:off x="6473951" y="4434839"/>
             <a:ext cx="4572000" cy="201168"/>
           </a:xfrm>
           <a:prstGeom prst="rect">
@@ -12241,7 +12302,7 @@
         </p:nvSpPr>
         <p:spPr>
           <a:xfrm>
-            <a:off x="6473951" y="4480560"/>
+            <a:off x="6473951" y="4709159"/>
             <a:ext cx="4572000" cy="201168"/>
           </a:xfrm>
           <a:prstGeom prst="rect">
@@ -12544,8 +12605,8 @@
         </p:nvSpPr>
         <p:spPr>
           <a:xfrm>
-            <a:off x="685800" y="1828800"/>
-            <a:ext cx="10835640" cy="3886200"/>
+            <a:off x="685800" y="2148840"/>
+            <a:ext cx="10835640" cy="3566160"/>
           </a:xfrm>
           <a:prstGeom prst="roundRect">
             <a:avLst>
@@ -12599,8 +12660,8 @@
         </p:blipFill>
         <p:spPr>
           <a:xfrm>
-            <a:off x="3132328" y="1993392"/>
-            <a:ext cx="5933440" cy="3337560"/>
+            <a:off x="3416808" y="2304288"/>
+            <a:ext cx="5364480" cy="3017520"/>
           </a:xfrm>
           <a:prstGeom prst="rect">
             <a:avLst/>
@@ -13522,7 +13583,7 @@
                 </a:solidFill>
                 <a:latin typeface="Aptos"/>
               </a:rPr>
-              <a:t>SOFTWARE_VALIDATED</a:t>
+              <a:t>FORMAL_PROOF*</a:t>
             </a:r>
           </a:p>
         </p:txBody>
@@ -13561,7 +13622,7 @@
                 </a:solidFill>
                 <a:latin typeface="Aptos"/>
               </a:rPr>
-              <a:t>proof work in repo</a:t>
+              <a:t>audited properties only; counts withheld</a:t>
             </a:r>
           </a:p>
         </p:txBody>
@@ -13950,7 +14011,7 @@
                 </a:solidFill>
                 <a:latin typeface="Aptos"/>
               </a:rPr>
-              <a:t>RETURN PATH</a:t>
+              <a:t>COMMERCIAL PATH</a:t>
             </a:r>
           </a:p>
         </p:txBody>
@@ -13989,7 +14050,7 @@
                 </a:solidFill>
                 <a:latin typeface="Aptos"/>
               </a:rPr>
-              <a:t>Don't outspend incumbents. Become their strategic acquisition.</a:t>
+              <a:t>Start with paid evaluation, then earn strategic options</a:t>
             </a:r>
           </a:p>
         </p:txBody>
@@ -14002,8 +14063,8 @@
         </p:nvSpPr>
         <p:spPr>
           <a:xfrm>
-            <a:off x="685800" y="1920240"/>
-            <a:ext cx="2468880" cy="2788920"/>
+            <a:off x="685800" y="2240280"/>
+            <a:ext cx="2468880" cy="2331720"/>
           </a:xfrm>
           <a:prstGeom prst="roundRect">
             <a:avLst>
@@ -14049,7 +14110,7 @@
         </p:nvSpPr>
         <p:spPr>
           <a:xfrm>
-            <a:off x="850392" y="2066543"/>
+            <a:off x="850392" y="2386584"/>
             <a:ext cx="1965960" cy="38100"/>
           </a:xfrm>
           <a:prstGeom prst="rect">
@@ -14092,7 +14153,7 @@
         </p:nvSpPr>
         <p:spPr>
           <a:xfrm>
-            <a:off x="850392" y="2286000"/>
+            <a:off x="850392" y="2615184"/>
             <a:ext cx="2103120" cy="438912"/>
           </a:xfrm>
           <a:prstGeom prst="rect">
@@ -14112,14 +14173,14 @@
               </a:spcAft>
             </a:pPr>
             <a:r>
-              <a:rPr sz="1350" b="1">
+              <a:rPr sz="1280" b="1">
                 <a:solidFill>
                   <a:srgbClr val="F4F8FF"/>
                 </a:solidFill>
                 <a:latin typeface="Aptos"/>
               </a:rPr>
-              <a:t>Measured proof
-(0–12 mo)</a:t>
+              <a:t>Proof review
+0-30 days</a:t>
             </a:r>
           </a:p>
         </p:txBody>
@@ -14132,8 +14193,8 @@
         </p:nvSpPr>
         <p:spPr>
           <a:xfrm>
-            <a:off x="850392" y="2834640"/>
-            <a:ext cx="2057400" cy="868680"/>
+            <a:off x="850392" y="3182112"/>
+            <a:ext cx="2057400" cy="640080"/>
           </a:xfrm>
           <a:prstGeom prst="rect">
             <a:avLst/>
@@ -14152,13 +14213,13 @@
               </a:spcAft>
             </a:pPr>
             <a:r>
-              <a:rPr sz="1050" b="0">
+              <a:rPr sz="1000" b="0">
                 <a:solidFill>
                   <a:srgbClr val="9FB1C7"/>
                 </a:solidFill>
                 <a:latin typeface="Aptos"/>
               </a:rPr>
-              <a:t>One workload. One baseline. One metric. Artifact-backed, correctness-verified.</a:t>
+              <a:t>Artifact review + fit question.</a:t>
             </a:r>
           </a:p>
         </p:txBody>
@@ -14171,8 +14232,8 @@
         </p:nvSpPr>
         <p:spPr>
           <a:xfrm>
-            <a:off x="3520440" y="1920240"/>
-            <a:ext cx="2468880" cy="2788920"/>
+            <a:off x="3520440" y="2240280"/>
+            <a:ext cx="2468880" cy="2331720"/>
           </a:xfrm>
           <a:prstGeom prst="roundRect">
             <a:avLst>
@@ -14218,7 +14279,7 @@
         </p:nvSpPr>
         <p:spPr>
           <a:xfrm>
-            <a:off x="3685032" y="2066543"/>
+            <a:off x="3685032" y="2386584"/>
             <a:ext cx="1965960" cy="38100"/>
           </a:xfrm>
           <a:prstGeom prst="rect">
@@ -14261,7 +14322,7 @@
         </p:nvSpPr>
         <p:spPr>
           <a:xfrm>
-            <a:off x="3685032" y="2286000"/>
+            <a:off x="3685032" y="2615184"/>
             <a:ext cx="2103120" cy="438912"/>
           </a:xfrm>
           <a:prstGeom prst="rect">
@@ -14281,14 +14342,14 @@
               </a:spcAft>
             </a:pPr>
             <a:r>
-              <a:rPr sz="1350" b="1">
+              <a:rPr sz="1280" b="1">
                 <a:solidFill>
                   <a:srgbClr val="F4F8FF"/>
                 </a:solidFill>
                 <a:latin typeface="Aptos"/>
               </a:rPr>
-              <a:t>IP &amp; diligence
-(6–18 mo)</a:t>
+              <a:t>Technical eval
+30-90 days</a:t>
             </a:r>
           </a:p>
         </p:txBody>
@@ -14301,8 +14362,8 @@
         </p:nvSpPr>
         <p:spPr>
           <a:xfrm>
-            <a:off x="3685032" y="2834640"/>
-            <a:ext cx="2057400" cy="868680"/>
+            <a:off x="3685032" y="3182112"/>
+            <a:ext cx="2057400" cy="640080"/>
           </a:xfrm>
           <a:prstGeom prst="rect">
             <a:avLst/>
@@ -14321,13 +14382,13 @@
               </a:spcAft>
             </a:pPr>
             <a:r>
-              <a:rPr sz="1050" b="0">
+              <a:rPr sz="1000" b="0">
                 <a:solidFill>
                   <a:srgbClr val="9FB1C7"/>
                 </a:solidFill>
                 <a:latin typeface="Aptos"/>
               </a:rPr>
-              <a:t>Patent conversion, prior-art review, counsel-reviewed packet.</a:t>
+              <a:t>Workload + baseline + metric.</a:t>
             </a:r>
           </a:p>
         </p:txBody>
@@ -14340,8 +14401,8 @@
         </p:nvSpPr>
         <p:spPr>
           <a:xfrm>
-            <a:off x="6355080" y="1920240"/>
-            <a:ext cx="2468880" cy="2788920"/>
+            <a:off x="6355080" y="2240280"/>
+            <a:ext cx="2468880" cy="2331720"/>
           </a:xfrm>
           <a:prstGeom prst="roundRect">
             <a:avLst>
@@ -14387,7 +14448,7 @@
         </p:nvSpPr>
         <p:spPr>
           <a:xfrm>
-            <a:off x="6519672" y="2066543"/>
+            <a:off x="6519672" y="2386584"/>
             <a:ext cx="1965960" cy="38100"/>
           </a:xfrm>
           <a:prstGeom prst="rect">
@@ -14430,7 +14491,7 @@
         </p:nvSpPr>
         <p:spPr>
           <a:xfrm>
-            <a:off x="6519672" y="2286000"/>
+            <a:off x="6519672" y="2615184"/>
             <a:ext cx="2103120" cy="438912"/>
           </a:xfrm>
           <a:prstGeom prst="rect">
@@ -14450,14 +14511,14 @@
               </a:spcAft>
             </a:pPr>
             <a:r>
-              <a:rPr sz="1350" b="1">
+              <a:rPr sz="1280" b="1">
                 <a:solidFill>
                   <a:srgbClr val="F4F8FF"/>
                 </a:solidFill>
                 <a:latin typeface="Aptos"/>
               </a:rPr>
-              <a:t>Design partners
-(12–24 mo)</a:t>
+              <a:t>Design partner
+3-12 mo</a:t>
             </a:r>
           </a:p>
         </p:txBody>
@@ -14470,8 +14531,8 @@
         </p:nvSpPr>
         <p:spPr>
           <a:xfrm>
-            <a:off x="6519672" y="2834640"/>
-            <a:ext cx="2057400" cy="868680"/>
+            <a:off x="6519672" y="3182112"/>
+            <a:ext cx="2057400" cy="640080"/>
           </a:xfrm>
           <a:prstGeom prst="rect">
             <a:avLst/>
@@ -14490,13 +14551,13 @@
               </a:spcAft>
             </a:pPr>
             <a:r>
-              <a:rPr sz="1050" b="0">
+              <a:rPr sz="1000" b="0">
                 <a:solidFill>
                   <a:srgbClr val="9FB1C7"/>
                 </a:solidFill>
                 <a:latin typeface="Aptos"/>
               </a:rPr>
-              <a:t>Paid evaluations → design-partner agreements → IP licensing value.</a:t>
+              <a:t>Measured artifact + integration learning.</a:t>
             </a:r>
           </a:p>
         </p:txBody>
@@ -14509,8 +14570,8 @@
         </p:nvSpPr>
         <p:spPr>
           <a:xfrm>
-            <a:off x="9189720" y="1920240"/>
-            <a:ext cx="2468880" cy="2788920"/>
+            <a:off x="9189720" y="2240280"/>
+            <a:ext cx="2468880" cy="2331720"/>
           </a:xfrm>
           <a:prstGeom prst="roundRect">
             <a:avLst>
@@ -14556,7 +14617,7 @@
         </p:nvSpPr>
         <p:spPr>
           <a:xfrm>
-            <a:off x="9354312" y="2066543"/>
+            <a:off x="9354312" y="2386584"/>
             <a:ext cx="1965960" cy="38100"/>
           </a:xfrm>
           <a:prstGeom prst="rect">
@@ -14599,7 +14660,7 @@
         </p:nvSpPr>
         <p:spPr>
           <a:xfrm>
-            <a:off x="9354312" y="2286000"/>
+            <a:off x="9354312" y="2615184"/>
             <a:ext cx="2103120" cy="438912"/>
           </a:xfrm>
           <a:prstGeom prst="rect">
@@ -14619,14 +14680,14 @@
               </a:spcAft>
             </a:pPr>
             <a:r>
-              <a:rPr sz="1350" b="1">
+              <a:rPr sz="1280" b="1">
                 <a:solidFill>
                   <a:srgbClr val="F4F8FF"/>
                 </a:solidFill>
                 <a:latin typeface="Aptos"/>
               </a:rPr>
-              <a:t>Strategic outcome
-(18–36 mo)</a:t>
+              <a:t>Licensing diligence
+12-24 mo</a:t>
             </a:r>
           </a:p>
         </p:txBody>
@@ -14639,8 +14700,8 @@
         </p:nvSpPr>
         <p:spPr>
           <a:xfrm>
-            <a:off x="9354312" y="2834640"/>
-            <a:ext cx="2057400" cy="868680"/>
+            <a:off x="9354312" y="3182112"/>
+            <a:ext cx="2057400" cy="640080"/>
           </a:xfrm>
           <a:prstGeom prst="rect">
             <a:avLst/>
@@ -14659,13 +14720,13 @@
               </a:spcAft>
             </a:pPr>
             <a:r>
-              <a:rPr sz="1050" b="0">
+              <a:rPr sz="1000" b="0">
                 <a:solidFill>
                   <a:srgbClr val="9FB1C7"/>
                 </a:solidFill>
                 <a:latin typeface="Aptos"/>
               </a:rPr>
-              <a:t>License, partner, or be acquired by a chip/platform company at IP premium.</a:t>
+              <a:t>Partner review only if proof holds.</a:t>
             </a:r>
           </a:p>
         </p:txBody>
@@ -14704,7 +14765,7 @@
                 </a:solidFill>
                 <a:latin typeface="Aptos"/>
               </a:rPr>
-              <a:t>Comparable IP architecture acquisitions in semiconductor history: $50M–$400M+ for validated compute primitives. ATOMiK's path: proof → IP value → strategic partner.</a:t>
+              <a:t>Capital buys the evidence path: proof review, measured workload artifact, IP packet, ASIC feasibility.</a:t>
             </a:r>
           </a:p>
         </p:txBody>
@@ -14743,7 +14804,7 @@
                 </a:solidFill>
                 <a:latin typeface="Aptos"/>
               </a:rPr>
-              <a:t>Strategic outcome framing only. No acquisition is guaranteed or implied. Returns are speculative and subject to risk.</a:t>
+              <a:t>No acquisition, valuation, or return multiple is guaranteed or implied.</a:t>
             </a:r>
           </a:p>
         </p:txBody>

</xml_diff>